<commit_message>
release: hx-lite v1.02 — Template package/docx delivery & Check terminology
Propagate Guide template packages (incl. .docx) through export, sync, and
shell path layout; align gates/docs/PPTX to Check wording and nhx check.
</commit_message>
<xml_diff>
--- a/docs/HX应用介绍.pptx
+++ b/docs/HX应用介绍.pptx
@@ -2196,7 +2196,7 @@
                 <a:ea typeface="Microsoft YaHei" pitchFamily="34" charset="-122"/>
                 <a:cs typeface="Microsoft YaHei" pitchFamily="34" charset="-120"/>
               </a:rPr>
-              <a:t>WebUI 组织治理  ·  nhx 本地交付  ·  Guide / Sensor 驱动</a:t>
+              <a:t>WebUI 组织治理  ·  nhx 本地交付  ·  Guide / Check 驱动</a:t>
             </a:r>
             <a:endParaRPr lang="en-US" sz="1500" dirty="0"/>
           </a:p>
@@ -2857,7 +2857,7 @@
                 <a:ea typeface="Microsoft YaHei" pitchFamily="34" charset="-122"/>
                 <a:cs typeface="Microsoft YaHei" pitchFamily="34" charset="-120"/>
               </a:rPr>
-              <a:t>在 IDE 执行 /nhx-&lt;stage&gt;-&lt;task&gt; 时，带入该任务绑定的 Guide 与 Sensor 检查要求</a:t>
+              <a:t>执行 /nhx-&lt;stage&gt;-&lt;task&gt; 时注入 Guide；产物扩展名跟随 Template 主文件（如 .docx）</a:t>
             </a:r>
             <a:endParaRPr lang="en-US" sz="1300" dirty="0"/>
           </a:p>
@@ -3039,7 +3039,7 @@
                 <a:ea typeface="Microsoft YaHei" pitchFamily="34" charset="-122"/>
                 <a:cs typeface="Microsoft YaHei" pitchFamily="34" charset="-120"/>
               </a:rPr>
-              <a:t>Sensor · 反馈门禁</a:t>
+              <a:t>Check · 反馈门禁</a:t>
             </a:r>
             <a:endParaRPr lang="en-US" sz="2800" dirty="0"/>
           </a:p>
@@ -3561,7 +3561,7 @@
                 <a:ea typeface="Microsoft YaHei" pitchFamily="34" charset="-122"/>
                 <a:cs typeface="Microsoft YaHei" pitchFamily="34" charset="-120"/>
               </a:rPr>
-              <a:t>file.exists · doc.sections_complete · approval.*</a:t>
+              <a:t>file.exists · file.min_bytes · doc.sections_complete · approval.*</a:t>
             </a:r>
             <a:endParaRPr lang="en-US" sz="1200" dirty="0"/>
           </a:p>
@@ -3904,7 +3904,7 @@
                 <a:ea typeface="Microsoft YaHei" pitchFamily="34" charset="-122"/>
                 <a:cs typeface="Microsoft YaHei" pitchFamily="34" charset="-120"/>
               </a:rPr>
-              <a:t>Sensor 触发通道</a:t>
+              <a:t>Check 触发通道</a:t>
             </a:r>
             <a:endParaRPr lang="en-US" sz="2800" dirty="0"/>
           </a:p>
@@ -4460,7 +4460,7 @@
                 <a:ea typeface="Microsoft YaHei" pitchFamily="34" charset="-122"/>
                 <a:cs typeface="Microsoft YaHei" pitchFamily="34" charset="-120"/>
               </a:rPr>
-              <a:t>nhx sensor check</a:t>
+              <a:t>nhx check</a:t>
             </a:r>
             <a:endParaRPr lang="en-US" sz="1600" dirty="0"/>
           </a:p>
@@ -5724,7 +5724,7 @@
                 <a:ea typeface="Consolas" pitchFamily="34" charset="-122"/>
                 <a:cs typeface="Consolas" pitchFamily="34" charset="-120"/>
               </a:rPr>
-              <a:t>nhx sensor check …</a:t>
+              <a:t>nhx check …</a:t>
             </a:r>
             <a:endParaRPr lang="en-US" sz="1300" dirty="0"/>
           </a:p>
@@ -5984,7 +5984,7 @@
                 <a:ea typeface="Microsoft YaHei" pitchFamily="34" charset="-122"/>
                 <a:cs typeface="Microsoft YaHei" pitchFamily="34" charset="-120"/>
               </a:rPr>
-              <a:t>组织在 WebUI 治理资产，</a:t>
+              <a:t>组织在 WebUI 治理 Guide / Check，</a:t>
             </a:r>
             <a:endParaRPr lang="en-US" sz="2600" dirty="0"/>
           </a:p>
@@ -6123,7 +6123,7 @@
                 <a:ea typeface="Microsoft YaHei" pitchFamily="34" charset="-122"/>
                 <a:cs typeface="Microsoft YaHei" pitchFamily="34" charset="-120"/>
               </a:rPr>
-              <a:t>前馈 + 反馈双闭环</a:t>
+              <a:t>Guide 前馈 + Check 反馈</a:t>
             </a:r>
             <a:endParaRPr lang="en-US" sz="1500" dirty="0"/>
           </a:p>
@@ -8362,7 +8362,7 @@
                 <a:ea typeface="Microsoft YaHei" pitchFamily="34" charset="-122"/>
                 <a:cs typeface="Microsoft YaHei" pitchFamily="34" charset="-120"/>
               </a:rPr>
-              <a:t>通过 Guide（Skill / Template / Constraint 等）在生成前注入约束与上下文，指导 Agent 产出。</a:t>
+              <a:t>通过 Guide（Skill / Template package / Constraint 等）在生成前注入约束与上下文，指导 Agent 产出。</a:t>
             </a:r>
             <a:endParaRPr lang="en-US" sz="1300" dirty="0"/>
           </a:p>
@@ -8462,7 +8462,7 @@
                 <a:ea typeface="Microsoft YaHei" pitchFamily="34" charset="-122"/>
                 <a:cs typeface="Microsoft YaHei" pitchFamily="34" charset="-120"/>
               </a:rPr>
-              <a:t>通过 Sensor 校验与门禁（含人工审批），确认结果质量，并驱动更正与迭代闭环。</a:t>
+              <a:t>通过 Check 校验与门禁（含人工审批），确认结果质量，并驱动更正与迭代闭环。</a:t>
             </a:r>
             <a:endParaRPr lang="en-US" sz="1300" dirty="0"/>
           </a:p>
@@ -8930,7 +8930,7 @@
                 <a:ea typeface="Microsoft YaHei" pitchFamily="34" charset="-122"/>
                 <a:cs typeface="Microsoft YaHei" pitchFamily="34" charset="-120"/>
               </a:rPr>
-              <a:t>Sensor 反馈</a:t>
+              <a:t>Check 反馈</a:t>
             </a:r>
             <a:endParaRPr lang="en-US" sz="1300" dirty="0"/>
           </a:p>
@@ -9524,7 +9524,7 @@
                 <a:ea typeface="Microsoft YaHei" pitchFamily="34" charset="-122"/>
                 <a:cs typeface="Microsoft YaHei" pitchFamily="34" charset="-120"/>
               </a:rPr>
-              <a:t>▸  Guide &amp; Sensor 资产治理</a:t>
+              <a:t>▸  Guide &amp; Check 资产治理</a:t>
             </a:r>
             <a:endParaRPr lang="en-US" sz="1400" dirty="0"/>
           </a:p>
@@ -9780,7 +9780,7 @@
                 <a:ea typeface="Microsoft YaHei" pitchFamily="34" charset="-122"/>
                 <a:cs typeface="Microsoft YaHei" pitchFamily="34" charset="-120"/>
               </a:rPr>
-              <a:t>▸  init / sync 拉资产并投影 IDE</a:t>
+              <a:t>▸  init / sync（含 package）投影 IDE</a:t>
             </a:r>
             <a:endParaRPr lang="en-US" sz="1400" dirty="0"/>
           </a:p>
@@ -9858,7 +9858,7 @@
                 <a:ea typeface="Microsoft YaHei" pitchFamily="34" charset="-122"/>
                 <a:cs typeface="Microsoft YaHei" pitchFamily="34" charset="-120"/>
               </a:rPr>
-              <a:t>▸  IDE Hooks 驱动 Sensor</a:t>
+              <a:t>▸  IDE Hooks 驱动 Check</a:t>
             </a:r>
             <a:endParaRPr lang="en-US" sz="1400" dirty="0"/>
           </a:p>
@@ -9936,7 +9936,7 @@
                 <a:ea typeface="Microsoft YaHei" pitchFamily="34" charset="-122"/>
                 <a:cs typeface="Microsoft YaHei" pitchFamily="34" charset="-120"/>
               </a:rPr>
-              <a:t>▸  approve 发起人工审批</a:t>
+              <a:t>▸  check / approve 门禁与审批</a:t>
             </a:r>
             <a:endParaRPr lang="en-US" sz="1400" dirty="0"/>
           </a:p>
@@ -10157,7 +10157,7 @@
                 <a:ea typeface="Microsoft YaHei" pitchFamily="34" charset="-122"/>
                 <a:cs typeface="Microsoft YaHei" pitchFamily="34" charset="-120"/>
               </a:rPr>
-              <a:t>Profile → Stage → Task → Guide / Sensor（无 Suite 中间层）</a:t>
+              <a:t>Profile → Stage → Task → Guide / Check（无 Suite 中间层）</a:t>
             </a:r>
             <a:endParaRPr lang="en-US" sz="1300" dirty="0"/>
           </a:p>
@@ -10646,7 +10646,7 @@
                 <a:ea typeface="Microsoft YaHei" pitchFamily="34" charset="-122"/>
                 <a:cs typeface="Microsoft YaHei" pitchFamily="34" charset="-120"/>
               </a:rPr>
-              <a:t>直接绑定 Guide + Sensor</a:t>
+              <a:t>直接绑定 Guide + Check</a:t>
             </a:r>
             <a:endParaRPr lang="en-US" sz="1200" dirty="0"/>
           </a:p>
@@ -10916,7 +10916,7 @@
                 <a:ea typeface="Microsoft YaHei" pitchFamily="34" charset="-122"/>
                 <a:cs typeface="Microsoft YaHei" pitchFamily="34" charset="-120"/>
               </a:rPr>
-              <a:t>Sensor</a:t>
+              <a:t>Check</a:t>
             </a:r>
             <a:endParaRPr lang="en-US" sz="1800" dirty="0"/>
           </a:p>
@@ -11356,7 +11356,7 @@
                 <a:ea typeface="Microsoft YaHei" pitchFamily="34" charset="-122"/>
                 <a:cs typeface="Microsoft YaHei" pitchFamily="34" charset="-120"/>
               </a:rPr>
-              <a:t>资产可定制，按 Stage 编排 Guide 与 Sensor</a:t>
+              <a:t>资产可定制，按 Stage 编排 Guide 与 Check</a:t>
             </a:r>
             <a:endParaRPr lang="en-US" sz="1300" dirty="0"/>
           </a:p>
@@ -13065,7 +13065,7 @@
                 <a:ea typeface="Microsoft YaHei" pitchFamily="34" charset="-122"/>
                 <a:cs typeface="Microsoft YaHei" pitchFamily="34" charset="-120"/>
               </a:rPr>
-              <a:t>拉资产与绑定</a:t>
+              <a:t>含 package 模版同步</a:t>
             </a:r>
             <a:endParaRPr lang="en-US" sz="1200" dirty="0"/>
           </a:p>
@@ -13517,7 +13517,7 @@
                 <a:ea typeface="Microsoft YaHei" pitchFamily="34" charset="-122"/>
                 <a:cs typeface="Microsoft YaHei" pitchFamily="34" charset="-120"/>
               </a:rPr>
-              <a:t>当前支持 8 类 Guide Kind</a:t>
+              <a:t>7 类内置 + 组织自定义 guide.*</a:t>
             </a:r>
             <a:endParaRPr lang="en-US" sz="1300" dirty="0"/>
           </a:p>
@@ -13911,7 +13911,7 @@
                 <a:ea typeface="Microsoft YaHei" pitchFamily="34" charset="-122"/>
                 <a:cs typeface="Microsoft YaHei" pitchFamily="34" charset="-120"/>
               </a:rPr>
-              <a:t>产出模板</a:t>
+              <a:t>产出模板 / package</a:t>
             </a:r>
             <a:endParaRPr lang="en-US" sz="1100" dirty="0"/>
           </a:p>
@@ -14582,7 +14582,7 @@
                   <a:srgbClr val="FFFFFF"/>
                 </a:solidFill>
               </a:rPr>
-              <a:t>CO</a:t>
+              <a:t>CU</a:t>
             </a:r>
             <a:endParaRPr lang="en-US" sz="1100" dirty="0"/>
           </a:p>
@@ -14621,7 +14621,7 @@
                 <a:ea typeface="Microsoft YaHei" pitchFamily="34" charset="-122"/>
                 <a:cs typeface="Microsoft YaHei" pitchFamily="34" charset="-120"/>
               </a:rPr>
-              <a:t>Codemod</a:t>
+              <a:t>Custom</a:t>
             </a:r>
             <a:endParaRPr lang="en-US" sz="1400" dirty="0"/>
           </a:p>
@@ -14660,7 +14660,7 @@
                 <a:ea typeface="Consolas" pitchFamily="34" charset="-122"/>
                 <a:cs typeface="Consolas" pitchFamily="34" charset="-120"/>
               </a:rPr>
-              <a:t>guide.codemod</a:t>
+              <a:t>guide.&lt;slug&gt;</a:t>
             </a:r>
             <a:endParaRPr lang="en-US" sz="1000" dirty="0"/>
           </a:p>
@@ -14699,7 +14699,7 @@
                 <a:ea typeface="Microsoft YaHei" pitchFamily="34" charset="-122"/>
                 <a:cs typeface="Microsoft YaHei" pitchFamily="34" charset="-120"/>
               </a:rPr>
-              <a:t>改造指引</a:t>
+              <a:t>组织自定义类型</a:t>
             </a:r>
             <a:endParaRPr lang="en-US" sz="1100" dirty="0"/>
           </a:p>

</xml_diff>